<commit_message>
Pitch deck: fill in team (Habbig CEO, Cakarel CTO), unify design system
Title and Team & Ask slides now carry both founders with roles and
emails. Design unification pass: one shared baseline, height, and gap
for every 4-tile row (Why Now, Business Model, Execution), consistent
content start line and bullet sizes across all slides, and tightened
spacing against the footer.

Co-Authored-By: Claude Fable 5 <noreply@anthropic.com>
Claude-Session: https://claude.ai/code/session_013uvy26CD6n5dQUq2Hkga7c
</commit_message>
<xml_diff>
--- a/pitch-deck/narve-pitch-deck.pptx
+++ b/pitch-deck/narve-pitch-deck.pptx
@@ -865,7 +865,7 @@
           <a:lstStyle/>
           <a:p>
             <a:r>
-              <a:t>[PLACEHOLDER: founder bio — name, technical background, prior companies, domain credibility in markets or ML.] What the repo already evidences: execution breadth (every service documented, tested, deployable — including a 3,903-line risk/position-sizing build with Kelly sizing, Black-Scholes Greeks, and circuit breakers), operational maturity (CI, pre-deploy snapshots, production hardening flags, partner onboarding docs), and intellectual honesty as a working style (4-agent adversarial audit that caught a backtest off-by-one; Newey-West/Bonferroni statistical discipline). [PLACEHOLDER: raise amount and terms.] Framing for the close: this is not build-risk capital — product, billing rail, tests, and deploy tooling exist; capital converts a launch-ready system into a market position while the ledger moat compounds. Natural cost lines from the known risk register: X API spend (scales linearly with coverage), scraper resilience, semantic matching, per-tenant pipeline isolation, and launch GTM. Diligence items to have clean answers for: 'betyc' brand leftover, Stripe env vars unset in production, and README growth targets being goals, not traction. Then hand over the investor key and let the product finish the pitch.</a:t>
+              <a:t>Team: Julian Habbig (CEO, julian@habbig.com) and Sho Cakarel (CTO, sho@cakarel.com). [PLACEHOLDER: one sentence of background per founder — prior companies, domain credibility in markets or ML.] What the repo already evidences: execution breadth (every service documented, tested, deployable — including a 3,903-line risk/position-sizing build with Kelly sizing, Black-Scholes Greeks, and circuit breakers), operational maturity (CI, pre-deploy snapshots, production hardening flags, partner onboarding docs), and intellectual honesty as a working style (4-agent adversarial audit that caught a backtest off-by-one; Newey-West/Bonferroni statistical discipline). [PLACEHOLDER: raise amount and terms.] Framing for the close: this is not build-risk capital — product, billing rail, tests, and deploy tooling exist; capital converts a launch-ready system into a market position while the ledger moat compounds. Natural cost lines from the known risk register: X API spend (scales linearly with coverage), scraper resilience, semantic matching, per-tenant pipeline isolation, and launch GTM. Diligence items to have clean answers for: 'betyc' brand leftover, Stripe env vars unset in production, and README growth targets being goals, not traction. Then hand over the investor key and let the product finish the pitch.</a:t>
             </a:r>
           </a:p>
         </p:txBody>
@@ -4673,8 +4673,8 @@
         </p:nvSpPr>
         <p:spPr>
           <a:xfrm>
-            <a:off x="0" y="5349240"/>
-            <a:ext cx="12191695" cy="365760"/>
+            <a:off x="0" y="5303520"/>
+            <a:ext cx="12191695" cy="685800"/>
           </a:xfrm>
           <a:prstGeom prst="rect">
             <a:avLst/>
@@ -4687,15 +4687,67 @@
           </a:bodyPr>
           <a:lstStyle/>
           <a:p>
+            <a:pPr algn="ctr">
+              <a:spcAft>
+                <a:spcPts val="400"/>
+              </a:spcAft>
+            </a:pPr>
+            <a:r>
+              <a:rPr sz="1200" b="1" i="0">
+                <a:solidFill>
+                  <a:srgbClr val="EBEBEF"/>
+                </a:solidFill>
+                <a:latin typeface="Inter"/>
+              </a:rPr>
+              <a:t>Julian Habbig</a:t>
+            </a:r>
+            <a:r>
+              <a:rPr sz="1200" b="0" i="0">
+                <a:solidFill>
+                  <a:srgbClr val="8B8D98"/>
+                </a:solidFill>
+                <a:latin typeface="Inter"/>
+              </a:rPr>
+              <a:t> · CEO · julian@habbig.com</a:t>
+            </a:r>
+            <a:r>
+              <a:rPr sz="1200" b="0" i="0">
+                <a:solidFill>
+                  <a:srgbClr val="8B8D98"/>
+                </a:solidFill>
+                <a:latin typeface="Inter"/>
+              </a:rPr>
+              <a:t>      </a:t>
+            </a:r>
+            <a:r>
+              <a:rPr sz="1200" b="1" i="0">
+                <a:solidFill>
+                  <a:srgbClr val="EBEBEF"/>
+                </a:solidFill>
+                <a:latin typeface="Inter"/>
+              </a:rPr>
+              <a:t>Sho Cakarel</a:t>
+            </a:r>
+            <a:r>
+              <a:rPr sz="1200" b="0" i="0">
+                <a:solidFill>
+                  <a:srgbClr val="8B8D98"/>
+                </a:solidFill>
+                <a:latin typeface="Inter"/>
+              </a:rPr>
+              <a:t> · CTO · sho@cakarel.com</a:t>
+            </a:r>
+          </a:p>
+          <a:p>
             <a:pPr algn="ctr"/>
             <a:r>
-              <a:rPr sz="1150" b="0" i="0">
+              <a:rPr sz="1100" b="0" i="0">
                 <a:solidFill>
                   <a:srgbClr val="5C5E6A"/>
                 </a:solidFill>
                 <a:latin typeface="Inter"/>
               </a:rPr>
-              <a:t>[PLACEHOLDER: founder name + contact]   ·   Pre-seed   ·   July 2026</a:t>
+              <a:t>Pre-seed   ·   July 2026</a:t>
             </a:r>
           </a:p>
         </p:txBody>
@@ -5807,7 +5859,7 @@
               </a:spcAft>
             </a:pPr>
             <a:r>
-              <a:rPr sz="1300" b="1" i="0">
+              <a:rPr sz="1350" b="1" i="0">
                 <a:solidFill>
                   <a:srgbClr val="6366F1"/>
                 </a:solidFill>
@@ -5816,7 +5868,7 @@
               <a:t>—  </a:t>
             </a:r>
             <a:r>
-              <a:rPr sz="1300" b="1" i="0">
+              <a:rPr sz="1350" b="1" i="0">
                 <a:solidFill>
                   <a:srgbClr val="EBEBEF"/>
                 </a:solidFill>
@@ -5825,7 +5877,7 @@
               <a:t>Terminals, wallet trackers, Dune: </a:t>
             </a:r>
             <a:r>
-              <a:rPr sz="1300" b="0" i="0">
+              <a:rPr sz="1350" b="0" i="0">
                 <a:solidFill>
                   <a:srgbClr val="8B8D98"/>
                 </a:solidFill>
@@ -5844,7 +5896,7 @@
               </a:spcAft>
             </a:pPr>
             <a:r>
-              <a:rPr sz="1300" b="1" i="0">
+              <a:rPr sz="1350" b="1" i="0">
                 <a:solidFill>
                   <a:srgbClr val="6366F1"/>
                 </a:solidFill>
@@ -5853,7 +5905,7 @@
               <a:t>—  </a:t>
             </a:r>
             <a:r>
-              <a:rPr sz="1300" b="1" i="0">
+              <a:rPr sz="1350" b="1" i="0">
                 <a:solidFill>
                   <a:srgbClr val="EBEBEF"/>
                 </a:solidFill>
@@ -5862,7 +5914,7 @@
               <a:t>LunarCrush, Santiment: </a:t>
             </a:r>
             <a:r>
-              <a:rPr sz="1300" b="0" i="0">
+              <a:rPr sz="1350" b="0" i="0">
                 <a:solidFill>
                   <a:srgbClr val="8B8D98"/>
                 </a:solidFill>
@@ -5881,7 +5933,7 @@
               </a:spcAft>
             </a:pPr>
             <a:r>
-              <a:rPr sz="1300" b="1" i="0">
+              <a:rPr sz="1350" b="1" i="0">
                 <a:solidFill>
                   <a:srgbClr val="6366F1"/>
                 </a:solidFill>
@@ -5890,7 +5942,7 @@
               <a:t>—  </a:t>
             </a:r>
             <a:r>
-              <a:rPr sz="1300" b="1" i="0">
+              <a:rPr sz="1350" b="1" i="0">
                 <a:solidFill>
                   <a:srgbClr val="EBEBEF"/>
                 </a:solidFill>
@@ -5899,7 +5951,7 @@
               <a:t>Metaculus, FutureSearch: </a:t>
             </a:r>
             <a:r>
-              <a:rPr sz="1300" b="0" i="0">
+              <a:rPr sz="1350" b="0" i="0">
                 <a:solidFill>
                   <a:srgbClr val="8B8D98"/>
                 </a:solidFill>
@@ -5918,7 +5970,7 @@
               </a:spcAft>
             </a:pPr>
             <a:r>
-              <a:rPr sz="1300" b="1" i="0">
+              <a:rPr sz="1350" b="1" i="0">
                 <a:solidFill>
                   <a:srgbClr val="6366F1"/>
                 </a:solidFill>
@@ -5927,7 +5979,7 @@
               <a:t>—  </a:t>
             </a:r>
             <a:r>
-              <a:rPr sz="1300" b="1" i="0">
+              <a:rPr sz="1350" b="1" i="0">
                 <a:solidFill>
                   <a:srgbClr val="EBEBEF"/>
                 </a:solidFill>
@@ -5936,7 +5988,7 @@
               <a:t>narve.ai alone: </a:t>
             </a:r>
             <a:r>
-              <a:rPr sz="1300" b="0" i="0">
+              <a:rPr sz="1350" b="0" i="0">
                 <a:solidFill>
                   <a:srgbClr val="8B8D98"/>
                 </a:solidFill>
@@ -7155,8 +7207,8 @@
         </p:nvSpPr>
         <p:spPr>
           <a:xfrm>
-            <a:off x="685800" y="2057400"/>
-            <a:ext cx="2624328" cy="1554480"/>
+            <a:off x="685800" y="2103120"/>
+            <a:ext cx="2533573" cy="1737360"/>
           </a:xfrm>
           <a:prstGeom prst="roundRect">
             <a:avLst>
@@ -7203,8 +7255,8 @@
         </p:nvSpPr>
         <p:spPr>
           <a:xfrm>
-            <a:off x="886968" y="2221992"/>
-            <a:ext cx="2221992" cy="1280160"/>
+            <a:off x="886968" y="2267712"/>
+            <a:ext cx="2131237" cy="1463040"/>
           </a:xfrm>
           <a:prstGeom prst="rect">
             <a:avLst/>
@@ -7274,7 +7326,7 @@
         </p:nvSpPr>
         <p:spPr>
           <a:xfrm>
-            <a:off x="685800" y="2258568"/>
+            <a:off x="685800" y="2304288"/>
             <a:ext cx="27432" cy="256032"/>
           </a:xfrm>
           <a:prstGeom prst="roundRect">
@@ -7320,8 +7372,8 @@
         </p:nvSpPr>
         <p:spPr>
           <a:xfrm>
-            <a:off x="3511296" y="2057400"/>
-            <a:ext cx="2624328" cy="1554480"/>
+            <a:off x="3447973" y="2103120"/>
+            <a:ext cx="2533573" cy="1737360"/>
           </a:xfrm>
           <a:prstGeom prst="roundRect">
             <a:avLst>
@@ -7368,8 +7420,8 @@
         </p:nvSpPr>
         <p:spPr>
           <a:xfrm>
-            <a:off x="3712464" y="2221992"/>
-            <a:ext cx="2221992" cy="1280160"/>
+            <a:off x="3649141" y="2267712"/>
+            <a:ext cx="2131237" cy="1463040"/>
           </a:xfrm>
           <a:prstGeom prst="rect">
             <a:avLst/>
@@ -7439,7 +7491,7 @@
         </p:nvSpPr>
         <p:spPr>
           <a:xfrm>
-            <a:off x="3511296" y="2258568"/>
+            <a:off x="3447973" y="2304288"/>
             <a:ext cx="27432" cy="256032"/>
           </a:xfrm>
           <a:prstGeom prst="roundRect">
@@ -7485,8 +7537,8 @@
         </p:nvSpPr>
         <p:spPr>
           <a:xfrm>
-            <a:off x="6336792" y="2057400"/>
-            <a:ext cx="2624328" cy="1554480"/>
+            <a:off x="6210146" y="2103120"/>
+            <a:ext cx="2533573" cy="1737360"/>
           </a:xfrm>
           <a:prstGeom prst="roundRect">
             <a:avLst>
@@ -7533,8 +7585,8 @@
         </p:nvSpPr>
         <p:spPr>
           <a:xfrm>
-            <a:off x="6537960" y="2221992"/>
-            <a:ext cx="2221992" cy="1280160"/>
+            <a:off x="6411314" y="2267712"/>
+            <a:ext cx="2131237" cy="1463040"/>
           </a:xfrm>
           <a:prstGeom prst="rect">
             <a:avLst/>
@@ -7604,7 +7656,7 @@
         </p:nvSpPr>
         <p:spPr>
           <a:xfrm>
-            <a:off x="6336792" y="2258568"/>
+            <a:off x="6210146" y="2304288"/>
             <a:ext cx="27432" cy="256032"/>
           </a:xfrm>
           <a:prstGeom prst="roundRect">
@@ -7650,8 +7702,8 @@
         </p:nvSpPr>
         <p:spPr>
           <a:xfrm>
-            <a:off x="9162288" y="2057400"/>
-            <a:ext cx="2624328" cy="1554480"/>
+            <a:off x="8972319" y="2103120"/>
+            <a:ext cx="2533573" cy="1737360"/>
           </a:xfrm>
           <a:prstGeom prst="roundRect">
             <a:avLst>
@@ -7698,8 +7750,8 @@
         </p:nvSpPr>
         <p:spPr>
           <a:xfrm>
-            <a:off x="9363456" y="2221992"/>
-            <a:ext cx="2221992" cy="1280160"/>
+            <a:off x="9173487" y="2267712"/>
+            <a:ext cx="2131237" cy="1463040"/>
           </a:xfrm>
           <a:prstGeom prst="rect">
             <a:avLst/>
@@ -7769,7 +7821,7 @@
         </p:nvSpPr>
         <p:spPr>
           <a:xfrm>
-            <a:off x="9162288" y="2258568"/>
+            <a:off x="8972319" y="2304288"/>
             <a:ext cx="27432" cy="256032"/>
           </a:xfrm>
           <a:prstGeom prst="roundRect">
@@ -7815,7 +7867,7 @@
         </p:nvSpPr>
         <p:spPr>
           <a:xfrm>
-            <a:off x="685800" y="3977639"/>
+            <a:off x="685800" y="4114800"/>
             <a:ext cx="10820095" cy="960120"/>
           </a:xfrm>
           <a:prstGeom prst="roundRect">
@@ -7863,7 +7915,7 @@
         </p:nvSpPr>
         <p:spPr>
           <a:xfrm>
-            <a:off x="1005840" y="3977639"/>
+            <a:off x="1005840" y="4114800"/>
             <a:ext cx="10180015" cy="960120"/>
           </a:xfrm>
           <a:prstGeom prst="rect">
@@ -7911,7 +7963,7 @@
         </p:nvSpPr>
         <p:spPr>
           <a:xfrm>
-            <a:off x="685800" y="5212080"/>
+            <a:off x="685800" y="5321808"/>
             <a:ext cx="10820095" cy="4206240"/>
           </a:xfrm>
           <a:prstGeom prst="rect">
@@ -7995,7 +8047,7 @@
                 </a:solidFill>
                 <a:latin typeface="Inter"/>
               </a:rPr>
-              <a:t>every signal paper-traded and force-settled; public backtest harness (Sharpe, drawdown). Zero user or revenue numbers on this slide — deliberately.</a:t>
+              <a:t>every signal paper-traded and force-settled; public backtest harness (Sharpe, drawdown).</a:t>
             </a:r>
           </a:p>
         </p:txBody>
@@ -9175,7 +9227,7 @@
                 </a:solidFill>
                 <a:latin typeface="Inter"/>
               </a:rPr>
-              <a:t>[PLACEHOLDER: Founder] built the entire stack — raising [PLACEHOLDER: $X] to switch it on.</a:t>
+              <a:t>Habbig &amp; Cakarel built the entire stack — raising [PLACEHOLDER: $X] to switch it on.</a:t>
             </a:r>
           </a:p>
         </p:txBody>
@@ -9267,30 +9319,84 @@
           </a:p>
           <a:p>
             <a:pPr>
-              <a:lnSpc>
-                <a:spcPct val="125000"/>
-              </a:lnSpc>
               <a:spcAft>
-                <a:spcPts val="1000"/>
+                <a:spcPts val="200"/>
               </a:spcAft>
             </a:pPr>
             <a:r>
-              <a:rPr sz="1300" b="1" i="0">
+              <a:rPr sz="1500" b="1" i="0">
                 <a:solidFill>
                   <a:srgbClr val="EBEBEF"/>
                 </a:solidFill>
                 <a:latin typeface="Inter"/>
               </a:rPr>
-              <a:t>[PLACEHOLDER: founder name] </a:t>
-            </a:r>
-            <a:r>
-              <a:rPr sz="1300" b="0" i="0">
+              <a:t>Julian Habbig</a:t>
+            </a:r>
+            <a:r>
+              <a:rPr sz="1250" b="1" i="0">
+                <a:solidFill>
+                  <a:srgbClr val="6366F1"/>
+                </a:solidFill>
+                <a:latin typeface="Inter"/>
+              </a:rPr>
+              <a:t>  ·  CEO</a:t>
+            </a:r>
+          </a:p>
+          <a:p>
+            <a:pPr>
+              <a:spcAft>
+                <a:spcPts val="900"/>
+              </a:spcAft>
+            </a:pPr>
+            <a:r>
+              <a:rPr sz="1150" b="0" i="0">
                 <a:solidFill>
                   <a:srgbClr val="8B8D98"/>
                 </a:solidFill>
                 <a:latin typeface="Inter"/>
               </a:rPr>
-              <a:t>— background, prior roles, relevant wins.</a:t>
+              <a:t>julian@habbig.com · [PLACEHOLDER: background, prior roles, relevant wins]</a:t>
+            </a:r>
+          </a:p>
+          <a:p>
+            <a:pPr>
+              <a:spcAft>
+                <a:spcPts val="200"/>
+              </a:spcAft>
+            </a:pPr>
+            <a:r>
+              <a:rPr sz="1500" b="1" i="0">
+                <a:solidFill>
+                  <a:srgbClr val="EBEBEF"/>
+                </a:solidFill>
+                <a:latin typeface="Inter"/>
+              </a:rPr>
+              <a:t>Sho Cakarel</a:t>
+            </a:r>
+            <a:r>
+              <a:rPr sz="1250" b="1" i="0">
+                <a:solidFill>
+                  <a:srgbClr val="6366F1"/>
+                </a:solidFill>
+                <a:latin typeface="Inter"/>
+              </a:rPr>
+              <a:t>  ·  CTO</a:t>
+            </a:r>
+          </a:p>
+          <a:p>
+            <a:pPr>
+              <a:spcAft>
+                <a:spcPts val="900"/>
+              </a:spcAft>
+            </a:pPr>
+            <a:r>
+              <a:rPr sz="1150" b="0" i="0">
+                <a:solidFill>
+                  <a:srgbClr val="8B8D98"/>
+                </a:solidFill>
+                <a:latin typeface="Inter"/>
+              </a:rPr>
+              <a:t>sho@cakarel.com · [PLACEHOLDER: background, prior roles, relevant wins]</a:t>
             </a:r>
           </a:p>
           <a:p>
@@ -9298,12 +9404,9 @@
               <a:lnSpc>
                 <a:spcPct val="125000"/>
               </a:lnSpc>
-              <a:spcAft>
-                <a:spcPts val="1000"/>
-              </a:spcAft>
             </a:pPr>
             <a:r>
-              <a:rPr sz="1300" b="1" i="0">
+              <a:rPr sz="1250" b="1" i="0">
                 <a:solidFill>
                   <a:srgbClr val="EBEBEF"/>
                 </a:solidFill>
@@ -9312,41 +9415,13 @@
               <a:t>The repo is the résumé: </a:t>
             </a:r>
             <a:r>
-              <a:rPr sz="1300" b="0" i="0">
+              <a:rPr sz="1250" b="0" i="0">
                 <a:solidFill>
                   <a:srgbClr val="8B8D98"/>
                 </a:solidFill>
                 <a:latin typeface="Inter"/>
               </a:rPr>
               <a:t>15 dashboards, 2 trading bots, one auth/billing gateway, one 20-model quant toolkit — documented, tested, deployable.</a:t>
-            </a:r>
-          </a:p>
-          <a:p>
-            <a:pPr>
-              <a:lnSpc>
-                <a:spcPct val="125000"/>
-              </a:lnSpc>
-              <a:spcAft>
-                <a:spcPts val="1000"/>
-              </a:spcAft>
-            </a:pPr>
-            <a:r>
-              <a:rPr sz="1300" b="1" i="0">
-                <a:solidFill>
-                  <a:srgbClr val="EBEBEF"/>
-                </a:solidFill>
-                <a:latin typeface="Inter"/>
-              </a:rPr>
-              <a:t>Working style as brand: </a:t>
-            </a:r>
-            <a:r>
-              <a:rPr sz="1300" b="0" i="0">
-                <a:solidFill>
-                  <a:srgbClr val="8B8D98"/>
-                </a:solidFill>
-                <a:latin typeface="Inter"/>
-              </a:rPr>
-              <a:t>null-benchmarked models, after-cost edges, honest failure reporting.</a:t>
             </a:r>
           </a:p>
         </p:txBody>
@@ -9785,7 +9860,7 @@
         </p:nvSpPr>
         <p:spPr>
           <a:xfrm>
-            <a:off x="685800" y="1965960"/>
+            <a:off x="685800" y="2011680"/>
             <a:ext cx="6126480" cy="4206240"/>
           </a:xfrm>
           <a:prstGeom prst="rect">
@@ -9956,7 +10031,7 @@
         </p:nvSpPr>
         <p:spPr>
           <a:xfrm>
-            <a:off x="7315200" y="2148840"/>
+            <a:off x="7315200" y="2011680"/>
             <a:ext cx="4160520" cy="1417320"/>
           </a:xfrm>
           <a:prstGeom prst="roundRect">
@@ -10004,7 +10079,7 @@
         </p:nvSpPr>
         <p:spPr>
           <a:xfrm>
-            <a:off x="7534656" y="2313432"/>
+            <a:off x="7534656" y="2176272"/>
             <a:ext cx="3721608" cy="1188720"/>
           </a:xfrm>
           <a:prstGeom prst="rect">
@@ -10114,7 +10189,7 @@
         </p:nvSpPr>
         <p:spPr>
           <a:xfrm>
-            <a:off x="7315200" y="3794760"/>
+            <a:off x="7315200" y="3657600"/>
             <a:ext cx="4160520" cy="1417320"/>
           </a:xfrm>
           <a:prstGeom prst="roundRect">
@@ -10162,7 +10237,7 @@
         </p:nvSpPr>
         <p:spPr>
           <a:xfrm>
-            <a:off x="7534656" y="3959352"/>
+            <a:off x="7534656" y="3822192"/>
             <a:ext cx="3721608" cy="1188720"/>
           </a:xfrm>
           <a:prstGeom prst="rect">
@@ -10476,7 +10551,7 @@
         </p:nvSpPr>
         <p:spPr>
           <a:xfrm>
-            <a:off x="685800" y="1874519"/>
+            <a:off x="685800" y="2011680"/>
             <a:ext cx="10820095" cy="4206240"/>
           </a:xfrm>
           <a:prstGeom prst="rect">
@@ -13058,7 +13133,7 @@
               </a:spcAft>
             </a:pPr>
             <a:r>
-              <a:rPr sz="1300" b="1" i="0">
+              <a:rPr sz="1350" b="1" i="0">
                 <a:solidFill>
                   <a:srgbClr val="6366F1"/>
                 </a:solidFill>
@@ -13067,7 +13142,7 @@
               <a:t>—  </a:t>
             </a:r>
             <a:r>
-              <a:rPr sz="1300" b="1" i="0">
+              <a:rPr sz="1350" b="1" i="0">
                 <a:solidFill>
                   <a:srgbClr val="EBEBEF"/>
                 </a:solidFill>
@@ -13076,7 +13151,7 @@
               <a:t>Cost-engineered extraction. </a:t>
             </a:r>
             <a:r>
-              <a:rPr sz="1300" b="0" i="0">
+              <a:rPr sz="1350" b="0" i="0">
                 <a:solidFill>
                   <a:srgbClr val="8B8D98"/>
                 </a:solidFill>
@@ -13095,7 +13170,7 @@
               </a:spcAft>
             </a:pPr>
             <a:r>
-              <a:rPr sz="1300" b="1" i="0">
+              <a:rPr sz="1350" b="1" i="0">
                 <a:solidFill>
                   <a:srgbClr val="6366F1"/>
                 </a:solidFill>
@@ -13104,7 +13179,7 @@
               <a:t>—  </a:t>
             </a:r>
             <a:r>
-              <a:rPr sz="1300" b="1" i="0">
+              <a:rPr sz="1350" b="1" i="0">
                 <a:solidFill>
                   <a:srgbClr val="EBEBEF"/>
                 </a:solidFill>
@@ -13113,7 +13188,7 @@
               <a:t>Credibility is earned, not asserted. </a:t>
             </a:r>
             <a:r>
-              <a:rPr sz="1300" b="0" i="0">
+              <a:rPr sz="1350" b="0" i="0">
                 <a:solidFill>
                   <a:srgbClr val="8B8D98"/>
                 </a:solidFill>
@@ -13132,7 +13207,7 @@
               </a:spcAft>
             </a:pPr>
             <a:r>
-              <a:rPr sz="1300" b="1" i="0">
+              <a:rPr sz="1350" b="1" i="0">
                 <a:solidFill>
                   <a:srgbClr val="6366F1"/>
                 </a:solidFill>
@@ -13141,7 +13216,7 @@
               <a:t>—  </a:t>
             </a:r>
             <a:r>
-              <a:rPr sz="1300" b="1" i="0">
+              <a:rPr sz="1350" b="1" i="0">
                 <a:solidFill>
                   <a:srgbClr val="EBEBEF"/>
                 </a:solidFill>
@@ -13150,7 +13225,7 @@
               <a:t>Liquidity-honest EV. </a:t>
             </a:r>
             <a:r>
-              <a:rPr sz="1300" b="0" i="0">
+              <a:rPr sz="1350" b="0" i="0">
                 <a:solidFill>
                   <a:srgbClr val="8B8D98"/>
                 </a:solidFill>
@@ -13374,7 +13449,7 @@
         <p:spPr>
           <a:xfrm>
             <a:off x="685800" y="2103120"/>
-            <a:ext cx="2624328" cy="1691640"/>
+            <a:ext cx="2533573" cy="1737360"/>
           </a:xfrm>
           <a:prstGeom prst="roundRect">
             <a:avLst>
@@ -13422,7 +13497,7 @@
         <p:spPr>
           <a:xfrm>
             <a:off x="886968" y="2267712"/>
-            <a:ext cx="2221992" cy="1417320"/>
+            <a:ext cx="2131237" cy="1463040"/>
           </a:xfrm>
           <a:prstGeom prst="rect">
             <a:avLst/>
@@ -13538,8 +13613,8 @@
         </p:nvSpPr>
         <p:spPr>
           <a:xfrm>
-            <a:off x="3511296" y="2103120"/>
-            <a:ext cx="2624328" cy="1691640"/>
+            <a:off x="3447973" y="2103120"/>
+            <a:ext cx="2533573" cy="1737360"/>
           </a:xfrm>
           <a:prstGeom prst="roundRect">
             <a:avLst>
@@ -13586,8 +13661,8 @@
         </p:nvSpPr>
         <p:spPr>
           <a:xfrm>
-            <a:off x="3712464" y="2267712"/>
-            <a:ext cx="2221992" cy="1417320"/>
+            <a:off x="3649141" y="2267712"/>
+            <a:ext cx="2131237" cy="1463040"/>
           </a:xfrm>
           <a:prstGeom prst="rect">
             <a:avLst/>
@@ -13657,7 +13732,7 @@
         </p:nvSpPr>
         <p:spPr>
           <a:xfrm>
-            <a:off x="3511296" y="2304288"/>
+            <a:off x="3447973" y="2304288"/>
             <a:ext cx="27432" cy="256032"/>
           </a:xfrm>
           <a:prstGeom prst="roundRect">
@@ -13703,8 +13778,8 @@
         </p:nvSpPr>
         <p:spPr>
           <a:xfrm>
-            <a:off x="6336792" y="2103120"/>
-            <a:ext cx="2624328" cy="1691640"/>
+            <a:off x="6210146" y="2103120"/>
+            <a:ext cx="2533573" cy="1737360"/>
           </a:xfrm>
           <a:prstGeom prst="roundRect">
             <a:avLst>
@@ -13751,8 +13826,8 @@
         </p:nvSpPr>
         <p:spPr>
           <a:xfrm>
-            <a:off x="6537960" y="2267712"/>
-            <a:ext cx="2221992" cy="1417320"/>
+            <a:off x="6411314" y="2267712"/>
+            <a:ext cx="2131237" cy="1463040"/>
           </a:xfrm>
           <a:prstGeom prst="rect">
             <a:avLst/>
@@ -13822,7 +13897,7 @@
         </p:nvSpPr>
         <p:spPr>
           <a:xfrm>
-            <a:off x="6336792" y="2304288"/>
+            <a:off x="6210146" y="2304288"/>
             <a:ext cx="27432" cy="256032"/>
           </a:xfrm>
           <a:prstGeom prst="roundRect">
@@ -13868,8 +13943,8 @@
         </p:nvSpPr>
         <p:spPr>
           <a:xfrm>
-            <a:off x="9162288" y="2103120"/>
-            <a:ext cx="2624328" cy="1691640"/>
+            <a:off x="8972319" y="2103120"/>
+            <a:ext cx="2533573" cy="1737360"/>
           </a:xfrm>
           <a:prstGeom prst="roundRect">
             <a:avLst>
@@ -13916,8 +13991,8 @@
         </p:nvSpPr>
         <p:spPr>
           <a:xfrm>
-            <a:off x="9363456" y="2267712"/>
-            <a:ext cx="2221992" cy="1417320"/>
+            <a:off x="9173487" y="2267712"/>
+            <a:ext cx="2131237" cy="1463040"/>
           </a:xfrm>
           <a:prstGeom prst="rect">
             <a:avLst/>
@@ -13987,7 +14062,7 @@
         </p:nvSpPr>
         <p:spPr>
           <a:xfrm>
-            <a:off x="9162288" y="2304288"/>
+            <a:off x="8972319" y="2304288"/>
             <a:ext cx="27432" cy="256032"/>
           </a:xfrm>
           <a:prstGeom prst="roundRect">
@@ -15145,7 +15220,7 @@
         </p:nvSpPr>
         <p:spPr>
           <a:xfrm>
-            <a:off x="685800" y="1965960"/>
+            <a:off x="685800" y="2011680"/>
             <a:ext cx="6035040" cy="4206240"/>
           </a:xfrm>
           <a:prstGeom prst="rect">
@@ -15316,7 +15391,7 @@
         </p:nvSpPr>
         <p:spPr>
           <a:xfrm>
-            <a:off x="7269480" y="1965960"/>
+            <a:off x="7269480" y="2011680"/>
             <a:ext cx="4206240" cy="3566160"/>
           </a:xfrm>
           <a:prstGeom prst="roundRect">
@@ -15364,7 +15439,7 @@
         </p:nvSpPr>
         <p:spPr>
           <a:xfrm>
-            <a:off x="7635240" y="4619965"/>
+            <a:off x="7635240" y="4665685"/>
             <a:ext cx="274320" cy="134915"/>
           </a:xfrm>
           <a:prstGeom prst="roundRect">
@@ -15410,7 +15485,7 @@
         </p:nvSpPr>
         <p:spPr>
           <a:xfrm>
-            <a:off x="8028432" y="4433996"/>
+            <a:off x="8028432" y="4479716"/>
             <a:ext cx="274320" cy="320884"/>
           </a:xfrm>
           <a:prstGeom prst="roundRect">
@@ -15456,7 +15531,7 @@
         </p:nvSpPr>
         <p:spPr>
           <a:xfrm>
-            <a:off x="8421624" y="4222205"/>
+            <a:off x="8421624" y="4267925"/>
             <a:ext cx="274320" cy="532675"/>
           </a:xfrm>
           <a:prstGeom prst="roundRect">
@@ -15502,7 +15577,7 @@
         </p:nvSpPr>
         <p:spPr>
           <a:xfrm>
-            <a:off x="8814816" y="3991685"/>
+            <a:off x="8814816" y="4037405"/>
             <a:ext cx="274320" cy="763195"/>
           </a:xfrm>
           <a:prstGeom prst="roundRect">
@@ -15548,7 +15623,7 @@
         </p:nvSpPr>
         <p:spPr>
           <a:xfrm>
-            <a:off x="9208008" y="3746154"/>
+            <a:off x="9208008" y="3791874"/>
             <a:ext cx="274320" cy="1008726"/>
           </a:xfrm>
           <a:prstGeom prst="roundRect">
@@ -15594,7 +15669,7 @@
         </p:nvSpPr>
         <p:spPr>
           <a:xfrm>
-            <a:off x="9601200" y="3487958"/>
+            <a:off x="9601200" y="3533678"/>
             <a:ext cx="274320" cy="1266922"/>
           </a:xfrm>
           <a:prstGeom prst="roundRect">
@@ -15640,7 +15715,7 @@
         </p:nvSpPr>
         <p:spPr>
           <a:xfrm>
-            <a:off x="9994392" y="3218731"/>
+            <a:off x="9994392" y="3264451"/>
             <a:ext cx="274320" cy="1536149"/>
           </a:xfrm>
           <a:prstGeom prst="roundRect">
@@ -15686,7 +15761,7 @@
         </p:nvSpPr>
         <p:spPr>
           <a:xfrm>
-            <a:off x="10387584" y="2939685"/>
+            <a:off x="10387584" y="2985405"/>
             <a:ext cx="274320" cy="1815195"/>
           </a:xfrm>
           <a:prstGeom prst="roundRect">
@@ -15732,7 +15807,7 @@
         </p:nvSpPr>
         <p:spPr>
           <a:xfrm>
-            <a:off x="10780776" y="2651760"/>
+            <a:off x="10780776" y="2697480"/>
             <a:ext cx="274320" cy="2103120"/>
           </a:xfrm>
           <a:prstGeom prst="roundRect">
@@ -15778,7 +15853,7 @@
         </p:nvSpPr>
         <p:spPr>
           <a:xfrm>
-            <a:off x="7635240" y="4745736"/>
+            <a:off x="7635240" y="4791456"/>
             <a:ext cx="3429000" cy="18288"/>
           </a:xfrm>
           <a:prstGeom prst="rect">
@@ -15822,7 +15897,7 @@
         </p:nvSpPr>
         <p:spPr>
           <a:xfrm>
-            <a:off x="7635240" y="2194560"/>
+            <a:off x="7635240" y="2240280"/>
             <a:ext cx="3474720" cy="548640"/>
           </a:xfrm>
           <a:prstGeom prst="rect">
@@ -15870,7 +15945,7 @@
         </p:nvSpPr>
         <p:spPr>
           <a:xfrm>
-            <a:off x="7635240" y="4864608"/>
+            <a:off x="7635240" y="4910328"/>
             <a:ext cx="3474720" cy="502920"/>
           </a:xfrm>
           <a:prstGeom prst="rect">
@@ -16122,7 +16197,7 @@
         </p:nvSpPr>
         <p:spPr>
           <a:xfrm>
-            <a:off x="685800" y="1965960"/>
+            <a:off x="685800" y="2011680"/>
             <a:ext cx="5623560" cy="4206240"/>
           </a:xfrm>
           <a:prstGeom prst="rect">
@@ -17386,7 +17461,7 @@
         <p:spPr>
           <a:xfrm>
             <a:off x="685800" y="2103120"/>
-            <a:ext cx="2624328" cy="1828800"/>
+            <a:ext cx="2533573" cy="1737360"/>
           </a:xfrm>
           <a:prstGeom prst="roundRect">
             <a:avLst>
@@ -17434,7 +17509,7 @@
         <p:spPr>
           <a:xfrm>
             <a:off x="886968" y="2304288"/>
-            <a:ext cx="2221992" cy="1554480"/>
+            <a:ext cx="2131237" cy="1371600"/>
           </a:xfrm>
           <a:prstGeom prst="rect">
             <a:avLst/>
@@ -17504,8 +17579,8 @@
         </p:nvSpPr>
         <p:spPr>
           <a:xfrm>
-            <a:off x="3511296" y="2103120"/>
-            <a:ext cx="2624328" cy="1828800"/>
+            <a:off x="3447973" y="2103120"/>
+            <a:ext cx="2533573" cy="1737360"/>
           </a:xfrm>
           <a:prstGeom prst="roundRect">
             <a:avLst>
@@ -17552,8 +17627,8 @@
         </p:nvSpPr>
         <p:spPr>
           <a:xfrm>
-            <a:off x="3712464" y="2304288"/>
-            <a:ext cx="2221992" cy="1554480"/>
+            <a:off x="3649141" y="2304288"/>
+            <a:ext cx="2131237" cy="1371600"/>
           </a:xfrm>
           <a:prstGeom prst="rect">
             <a:avLst/>
@@ -17623,8 +17698,8 @@
         </p:nvSpPr>
         <p:spPr>
           <a:xfrm>
-            <a:off x="6336792" y="2103120"/>
-            <a:ext cx="2624328" cy="1828800"/>
+            <a:off x="6210146" y="2103120"/>
+            <a:ext cx="2533573" cy="1737360"/>
           </a:xfrm>
           <a:prstGeom prst="roundRect">
             <a:avLst>
@@ -17671,8 +17746,8 @@
         </p:nvSpPr>
         <p:spPr>
           <a:xfrm>
-            <a:off x="6537960" y="2304288"/>
-            <a:ext cx="2221992" cy="1554480"/>
+            <a:off x="6411314" y="2304288"/>
+            <a:ext cx="2131237" cy="1371600"/>
           </a:xfrm>
           <a:prstGeom prst="rect">
             <a:avLst/>
@@ -17742,8 +17817,8 @@
         </p:nvSpPr>
         <p:spPr>
           <a:xfrm>
-            <a:off x="9162288" y="2103120"/>
-            <a:ext cx="2624328" cy="1828800"/>
+            <a:off x="8972319" y="2103120"/>
+            <a:ext cx="2533573" cy="1737360"/>
           </a:xfrm>
           <a:prstGeom prst="roundRect">
             <a:avLst>
@@ -17790,8 +17865,8 @@
         </p:nvSpPr>
         <p:spPr>
           <a:xfrm>
-            <a:off x="9363456" y="2304288"/>
-            <a:ext cx="2221992" cy="1554480"/>
+            <a:off x="9173487" y="2304288"/>
+            <a:ext cx="2131237" cy="1371600"/>
           </a:xfrm>
           <a:prstGeom prst="rect">
             <a:avLst/>
@@ -17861,7 +17936,7 @@
         </p:nvSpPr>
         <p:spPr>
           <a:xfrm>
-            <a:off x="685800" y="4434840"/>
+            <a:off x="685800" y="4297680"/>
             <a:ext cx="10820095" cy="4206240"/>
           </a:xfrm>
           <a:prstGeom prst="rect">

</xml_diff>

<commit_message>
Pitch deck: fill in the $50K pre-seed ask with draft use-of-funds split
Co-Authored-By: Claude Fable 5 <noreply@anthropic.com>
Claude-Session: https://claude.ai/code/session_013uvy26CD6n5dQUq2Hkga7c
</commit_message>
<xml_diff>
--- a/pitch-deck/narve-pitch-deck.pptx
+++ b/pitch-deck/narve-pitch-deck.pptx
@@ -865,7 +865,7 @@
           <a:lstStyle/>
           <a:p>
             <a:r>
-              <a:t>Team: Julian Habbig (CEO, julian@habbig.com) and Sho Cakarel (CTO, sho@cakarel.com). [PLACEHOLDER: one sentence of background per founder — prior companies, domain credibility in markets or ML.] What the repo already evidences: execution breadth (every service documented, tested, deployable — including a 3,903-line risk/position-sizing build with Kelly sizing, Black-Scholes Greeks, and circuit breakers), operational maturity (CI, pre-deploy snapshots, production hardening flags, partner onboarding docs), and intellectual honesty as a working style (4-agent adversarial audit that caught a backtest off-by-one; Newey-West/Bonferroni statistical discipline). [PLACEHOLDER: raise amount and terms.] Framing for the close: this is not build-risk capital — product, billing rail, tests, and deploy tooling exist; capital converts a launch-ready system into a market position while the ledger moat compounds. Natural cost lines from the known risk register: X API spend (scales linearly with coverage), scraper resilience, semantic matching, per-tenant pipeline isolation, and launch GTM. Diligence items to have clean answers for: 'betyc' brand leftover, Stripe env vars unset in production, and README growth targets being goals, not traction. Then hand over the investor key and let the product finish the pitch.</a:t>
+              <a:t>Team: Julian Habbig (CEO, julian@habbig.com) and Sho Cakarel (CTO, sho@cakarel.com). [PLACEHOLDER: one sentence of background per founder — prior companies, domain credibility in markets or ML.] The ask is $50,000 pre-seed. Framing for a small round: this is not build-risk capital — the product, billing rail, tests, and deploy tooling already exist. $50K converts a launch-ready system into a live market position: it covers the X API quota (~$100/mo Basic tier scales with coverage), LLM extraction spend, hosting, and a focused launch push, while the credibility ledger starts compounding — the asset a later entrant cannot rebuild. The use-of-funds split on the slide (~40/35/25) is a draft; adjust to actual budget before sending. What the repo already evidences: execution breadth (every service documented, tested, deployable — including a 3,903-line risk/position-sizing build with Kelly sizing, Black-Scholes Greeks, and circuit breakers), operational maturity (CI, pre-deploy snapshots, production hardening flags, partner onboarding docs), and intellectual honesty as a working style (4-agent adversarial audit that caught a backtest off-by-one; Newey-West/Bonferroni statistical discipline). [PLACEHOLDER: raise amount and terms.] Framing for the close: this is not build-risk capital — product, billing rail, tests, and deploy tooling exist; capital converts a launch-ready system into a market position while the ledger moat compounds. Natural cost lines from the known risk register: X API spend (scales linearly with coverage), scraper resilience, semantic matching, per-tenant pipeline isolation, and launch GTM. Diligence items to have clean answers for: 'betyc' brand leftover, Stripe env vars unset in production, and README growth targets being goals, not traction. Then hand over the investor key and let the product finish the pitch.</a:t>
             </a:r>
           </a:p>
         </p:txBody>
@@ -9221,13 +9221,13 @@
               </a:lnSpc>
             </a:pPr>
             <a:r>
-              <a:rPr sz="2400" b="1" i="0" spc="-30">
+              <a:rPr sz="2600" b="1" i="0" spc="-30">
                 <a:solidFill>
                   <a:srgbClr val="EBEBEF"/>
                 </a:solidFill>
                 <a:latin typeface="Inter"/>
               </a:rPr>
-              <a:t>Habbig &amp; Cakarel built the entire stack — raising [PLACEHOLDER: $X] to switch it on.</a:t>
+              <a:t>Habbig &amp; Cakarel built the entire stack — raising $50K to switch it on.</a:t>
             </a:r>
           </a:p>
         </p:txBody>
@@ -9518,13 +9518,22 @@
               </a:spcAft>
             </a:pPr>
             <a:r>
-              <a:rPr sz="2600" b="1" i="0">
+              <a:rPr sz="3000" b="1" i="0">
                 <a:solidFill>
                   <a:srgbClr val="EBEBEF"/>
                 </a:solidFill>
                 <a:latin typeface="Inter"/>
               </a:rPr>
-              <a:t>[PLACEHOLDER: $X]</a:t>
+              <a:t>$50,000</a:t>
+            </a:r>
+            <a:r>
+              <a:rPr sz="1300" b="0" i="0">
+                <a:solidFill>
+                  <a:srgbClr val="8B8D98"/>
+                </a:solidFill>
+                <a:latin typeface="Inter"/>
+              </a:rPr>
+              <a:t>  pre-seed</a:t>
             </a:r>
           </a:p>
           <a:p>
@@ -9552,7 +9561,7 @@
                 </a:solidFill>
                 <a:latin typeface="Inter"/>
               </a:rPr>
-              <a:t>[PLACEHOLDER: SAFE / priced, target close date]</a:t>
+              <a:t>SAFE — [PLACEHOLDER: cap/discount, target close date]</a:t>
             </a:r>
           </a:p>
           <a:p>
@@ -9580,7 +9589,7 @@
                 </a:solidFill>
                 <a:latin typeface="Inter"/>
               </a:rPr>
-              <a:t>[PLACEHOLDER: % data/API costs · % engineering (semantic matching, multi-tenancy) · % GTM]</a:t>
+              <a:t>~40% data &amp; API costs (X quota, LLM extraction) · ~35% engineering (semantic matching, multi-tenancy) · ~25% launch GTM</a:t>
             </a:r>
           </a:p>
           <a:p>
@@ -9599,7 +9608,7 @@
                 </a:solidFill>
                 <a:latin typeface="Inter"/>
               </a:rPr>
-              <a:t>Runway: </a:t>
+              <a:t>Buys: </a:t>
             </a:r>
             <a:r>
               <a:rPr sz="1250" b="0" i="0">
@@ -9608,7 +9617,7 @@
                 </a:solidFill>
                 <a:latin typeface="Inter"/>
               </a:rPr>
-              <a:t>[PLACEHOLDER: months + milestone commitments]</a:t>
+              <a:t>public launch + [PLACEHOLDER: X] months of ledger compounding — the dataset no later entrant can rebuild</a:t>
             </a:r>
           </a:p>
         </p:txBody>

</xml_diff>